<commit_message>
Add YouTube demo link to README and slide 13
Amp-Thread-ID: https://ampcode.com/threads/T-01a0805d-dcde-7427-ab00-0cf6a7ee8b26
Co-authored-by: Amp <amp@ampcode.com>
</commit_message>
<xml_diff>
--- a/presentation/QuantumHeadache_AntennaTilt.pptx
+++ b/presentation/QuantumHeadache_AntennaTilt.pptx
@@ -6645,6 +6645,101 @@
         </p:nvSpPr>
         <p:spPr>
           <a:xfrm>
+            <a:off x="548640" y="5074920"/>
+            <a:ext cx="11247120" cy="365760"/>
+          </a:xfrm>
+          <a:prstGeom prst="rect">
+            <a:avLst/>
+          </a:prstGeom>
+          <a:noFill/>
+          <a:ln/>
+        </p:spPr>
+        <p:txBody>
+          <a:bodyPr wrap="square" lIns="0" tIns="0" rIns="0" bIns="0" rtlCol="0" anchor="ctr"/>
+          <a:lstStyle/>
+          <a:p>
+            <a:pPr indent="0" marL="0">
+              <a:buNone/>
+            </a:pPr>
+            <a:r>
+              <a:rPr lang="en-US" sz="1600" dirty="0">
+                <a:solidFill>
+                  <a:srgbClr val="A9B4D0"/>
+                </a:solidFill>
+                <a:latin typeface="Calibri" pitchFamily="34" charset="0"/>
+                <a:ea typeface="Calibri" pitchFamily="34" charset="-122"/>
+                <a:cs typeface="Calibri" pitchFamily="34" charset="-120"/>
+              </a:rPr>
+              <a:t>Demo video: </a:t>
+            </a:r>
+            <a:pPr indent="0" marL="0">
+              <a:buNone/>
+            </a:pPr>
+            <a:r>
+              <a:rPr lang="en-US" sz="1600" u="sng" dirty="0">
+                <a:solidFill>
+                  <a:srgbClr val="2BD4C2"/>
+                </a:solidFill>
+                <a:latin typeface="Calibri" pitchFamily="34" charset="0"/>
+                <a:ea typeface="Calibri" pitchFamily="34" charset="-122"/>
+                <a:cs typeface="Calibri" pitchFamily="34" charset="-120"/>
+                <a:hlinkClick r:id="rId1" invalidUrl="" action="" tgtFrame="" tooltip="" history="1" highlightClick="0" endSnd="0">
+                  <a:extLst>
+                    <a:ext uri="{A12FA001-AC4F-418D-AE19-62706E023703}">
+                      <ahyp:hlinkClr xmlns:ahyp="http://schemas.microsoft.com/office/drawing/2018/hyperlinkcolor" val="tx"/>
+                    </a:ext>
+                  </a:extLst>
+                </a:hlinkClick>
+              </a:rPr>
+              <a:t>youtu.be/OSEtTWnRQhc</a:t>
+            </a:r>
+            <a:pPr indent="0" marL="0">
+              <a:buNone/>
+            </a:pPr>
+            <a:r>
+              <a:rPr lang="en-US" sz="1600" dirty="0">
+                <a:solidFill>
+                  <a:srgbClr val="A9B4D0"/>
+                </a:solidFill>
+                <a:latin typeface="Calibri" pitchFamily="34" charset="0"/>
+                <a:ea typeface="Calibri" pitchFamily="34" charset="-122"/>
+                <a:cs typeface="Calibri" pitchFamily="34" charset="-120"/>
+              </a:rPr>
+              <a:t>     Code: </a:t>
+            </a:r>
+            <a:pPr indent="0" marL="0">
+              <a:buNone/>
+            </a:pPr>
+            <a:r>
+              <a:rPr lang="en-US" sz="1600" u="sng" dirty="0">
+                <a:solidFill>
+                  <a:srgbClr val="2BD4C2"/>
+                </a:solidFill>
+                <a:latin typeface="Calibri" pitchFamily="34" charset="0"/>
+                <a:ea typeface="Calibri" pitchFamily="34" charset="-122"/>
+                <a:cs typeface="Calibri" pitchFamily="34" charset="-120"/>
+                <a:hlinkClick r:id="rId2" invalidUrl="" action="" tgtFrame="" tooltip="" history="1" highlightClick="0" endSnd="0">
+                  <a:extLst>
+                    <a:ext uri="{A12FA001-AC4F-418D-AE19-62706E023703}">
+                      <ahyp:hlinkClr xmlns:ahyp="http://schemas.microsoft.com/office/drawing/2018/hyperlinkcolor" val="tx"/>
+                    </a:ext>
+                  </a:extLst>
+                </a:hlinkClick>
+              </a:rPr>
+              <a:t>github.com/zuwasi/quantum-headache-antenna-tilt</a:t>
+            </a:r>
+            <a:endParaRPr lang="en-US" sz="1600" dirty="0"/>
+          </a:p>
+        </p:txBody>
+      </p:sp>
+      <p:sp>
+        <p:nvSpPr>
+          <p:cNvPr id="10" name="Text 7"/>
+          <p:cNvSpPr/>
+          <p:nvPr/>
+        </p:nvSpPr>
+        <p:spPr>
+          <a:xfrm>
             <a:off x="548640" y="5669280"/>
             <a:ext cx="11247120" cy="457200"/>
           </a:xfrm>

</xml_diff>

<commit_message>
Add slide 13: why quantum at 1000 qubits (classical tools vs a real 1000-qubit machine); deck is now 14 slides
Amp-Thread-ID: https://ampcode.com/threads/T-01a0805d-dcde-7427-ab00-0cf6a7ee8b26
Co-authored-by: Amp <amp@ampcode.com>
</commit_message>
<xml_diff>
--- a/presentation/QuantumHeadache_AntennaTilt.pptx
+++ b/presentation/QuantumHeadache_AntennaTilt.pptx
@@ -18,9 +18,10 @@
     <p:sldId id="266" r:id="rId12"/>
     <p:sldId id="267" r:id="rId13"/>
     <p:sldId id="268" r:id="rId14"/>
+    <p:sldId id="269" r:id="rId15"/>
   </p:sldIdLst>
   <p:notesMasterIdLst>
-    <p:notesMasterId r:id="rId15"/>
+    <p:notesMasterId r:id="rId16"/>
   </p:notesMasterIdLst>
   <p:sldSz cx="12192000" cy="6858000"/>
   <p:notesSz cx="6858000" cy="12192000"/>
@@ -866,7 +867,7 @@
           <a:p>
             <a:r>
               <a:rPr lang="en-US" dirty="0"/>
-              <a:t>Close with the group benchmark: one shared plan scores 1.379, per-region exact search 1.838 with 48 jobs, the hierarchy with QAOA 1.547 with 10 jobs; cycle 3 reaches 95 percent of the ceiling. Everything is reproducible from the GitHub repo; the demo video is on YouTube.</a:t>
+              <a:t>Scale slide. 1000 qubits is 500 antennas at 4 tilt levels or 250 at 10 levels. Brute force and exact simulation of the quantum algorithm are impossible past about 45 to 48 qubits; exact QUBO solvers stall; heuristics such as annealing are the real classical competitor and give good but unproven plans. Physical 1000-qubit machines exist today but gate errors mean the 13 000-CX layer needs error correction, so 1000 logical qubits is a 2028 to 2030 machine. Once available, a run is seconds to minutes, and the Qmod program is unchanged apart from the backend.</a:t>
             </a:r>
             <a:endParaRPr lang="en-US" dirty="0"/>
           </a:p>
@@ -890,6 +891,94 @@
             <a:fld id="{F7021451-1387-4CA6-816F-3879F97B5CBC}" type="slidenum">
               <a:rPr lang="en-US"/>
               <a:t>13</a:t>
+            </a:fld>
+            <a:endParaRPr lang="en-US"/>
+          </a:p>
+        </p:txBody>
+      </p:sp>
+    </p:spTree>
+    <p:extLst>
+      <p:ext uri="{BB962C8B-B14F-4D97-AF65-F5344CB8AC3E}">
+        <p14:creationId xmlns:p14="http://schemas.microsoft.com/office/powerpoint/2010/main" val="1024086991"/>
+      </p:ext>
+    </p:extLst>
+  </p:cSld>
+  <p:clrMapOvr>
+    <a:masterClrMapping/>
+  </p:clrMapOvr>
+</p:notes>
+</file>
+
+<file path=ppt/notesSlides/notesSlide14.xml><?xml version="1.0" encoding="utf-8"?>
+<p:notes xmlns:a="http://schemas.openxmlformats.org/drawingml/2006/main" xmlns:r="http://schemas.openxmlformats.org/officeDocument/2006/relationships" xmlns:p="http://schemas.openxmlformats.org/presentationml/2006/main">
+  <p:cSld>
+    <p:spTree>
+      <p:nvGrpSpPr>
+        <p:cNvPr id="1" name=""/>
+        <p:cNvGrpSpPr/>
+        <p:nvPr/>
+      </p:nvGrpSpPr>
+      <p:grpSpPr>
+        <a:xfrm>
+          <a:off x="0" y="0"/>
+          <a:ext cx="0" cy="0"/>
+          <a:chOff x="0" y="0"/>
+          <a:chExt cx="0" cy="0"/>
+        </a:xfrm>
+      </p:grpSpPr>
+      <p:sp>
+        <p:nvSpPr>
+          <p:cNvPr id="2" name="Slide Image Placeholder 1"/>
+          <p:cNvSpPr>
+            <a:spLocks noGrp="1" noRot="1" noChangeAspect="1"/>
+          </p:cNvSpPr>
+          <p:nvPr>
+            <p:ph type="sldImg"/>
+          </p:nvPr>
+        </p:nvSpPr>
+        <p:spPr/>
+      </p:sp>
+      <p:sp>
+        <p:nvSpPr>
+          <p:cNvPr id="3" name="Notes Placeholder 2"/>
+          <p:cNvSpPr>
+            <a:spLocks noGrp="1"/>
+          </p:cNvSpPr>
+          <p:nvPr>
+            <p:ph type="body" idx="1"/>
+          </p:nvPr>
+        </p:nvSpPr>
+        <p:spPr/>
+        <p:txBody>
+          <a:bodyPr/>
+          <a:lstStyle/>
+          <a:p>
+            <a:r>
+              <a:rPr lang="en-US" dirty="0"/>
+              <a:t>Close with the group benchmark: one shared plan scores 1.379, per-region exact search 1.838 with 48 jobs, the hierarchy with QAOA 1.547 with 10 jobs; cycle 3 reaches 95 percent of the ceiling. Everything is reproducible from the GitHub repo; the demo video is on YouTube.</a:t>
+            </a:r>
+            <a:endParaRPr lang="en-US" dirty="0"/>
+          </a:p>
+        </p:txBody>
+      </p:sp>
+      <p:sp>
+        <p:nvSpPr>
+          <p:cNvPr id="4" name="Slide Number Placeholder 3"/>
+          <p:cNvSpPr>
+            <a:spLocks noGrp="1"/>
+          </p:cNvSpPr>
+          <p:nvPr>
+            <p:ph type="sldNum" sz="quarter" idx="10"/>
+          </p:nvPr>
+        </p:nvSpPr>
+        <p:spPr/>
+        <p:txBody>
+          <a:bodyPr/>
+          <a:lstStyle/>
+          <a:p>
+            <a:fld id="{F7021451-1387-4CA6-816F-3879F97B5CBC}" type="slidenum">
+              <a:rPr lang="en-US"/>
+              <a:t>14</a:t>
             </a:fld>
             <a:endParaRPr lang="en-US"/>
           </a:p>
@@ -2003,7 +2092,7 @@
                 <a:ea typeface="Calibri" pitchFamily="34" charset="-122"/>
                 <a:cs typeface="Calibri" pitchFamily="34" charset="-120"/>
               </a:rPr>
-              <a:t>1 / 13</a:t>
+              <a:t>1 / 14</a:t>
             </a:r>
             <a:endParaRPr lang="en-US" sz="2800" dirty="0"/>
           </a:p>
@@ -2333,7 +2422,7 @@
                 <a:ea typeface="Calibri" pitchFamily="34" charset="-122"/>
                 <a:cs typeface="Calibri" pitchFamily="34" charset="-120"/>
               </a:rPr>
-              <a:t>10 / 13</a:t>
+              <a:t>10 / 14</a:t>
             </a:r>
             <a:endParaRPr lang="en-US" sz="2800" dirty="0"/>
           </a:p>
@@ -2392,7 +2481,7 @@
                 <a:ea typeface="Calibri" pitchFamily="34" charset="-122"/>
                 <a:cs typeface="Calibri" pitchFamily="34" charset="-120"/>
               </a:rPr>
-              <a:t>SLIDE 10 / 13   |   CLASSIQ</a:t>
+              <a:t>SLIDE 10 / 14   |   CLASSIQ</a:t>
             </a:r>
             <a:endParaRPr lang="en-US" sz="1100" dirty="0"/>
           </a:p>
@@ -2746,7 +2835,7 @@
                 <a:ea typeface="Calibri" pitchFamily="34" charset="-122"/>
                 <a:cs typeface="Calibri" pitchFamily="34" charset="-120"/>
               </a:rPr>
-              <a:t>11 / 13</a:t>
+              <a:t>11 / 14</a:t>
             </a:r>
             <a:endParaRPr lang="en-US" sz="2800" dirty="0"/>
           </a:p>
@@ -2805,7 +2894,7 @@
                 <a:ea typeface="Calibri" pitchFamily="34" charset="-122"/>
                 <a:cs typeface="Calibri" pitchFamily="34" charset="-120"/>
               </a:rPr>
-              <a:t>SLIDE 11 / 13   |   PROOF</a:t>
+              <a:t>SLIDE 11 / 14   |   PROOF</a:t>
             </a:r>
             <a:endParaRPr lang="en-US" sz="1100" dirty="0"/>
           </a:p>
@@ -3427,7 +3516,7 @@
                 <a:ea typeface="Calibri" pitchFamily="34" charset="-122"/>
                 <a:cs typeface="Calibri" pitchFamily="34" charset="-120"/>
               </a:rPr>
-              <a:t>12 / 13</a:t>
+              <a:t>12 / 14</a:t>
             </a:r>
             <a:endParaRPr lang="en-US" sz="2800" dirty="0"/>
           </a:p>
@@ -3486,7 +3575,7 @@
                 <a:ea typeface="Calibri" pitchFamily="34" charset="-122"/>
                 <a:cs typeface="Calibri" pitchFamily="34" charset="-120"/>
               </a:rPr>
-              <a:t>SLIDE 12 / 13   |   DESIGN CHOICE</a:t>
+              <a:t>SLIDE 12 / 14   |   DESIGN CHOICE</a:t>
             </a:r>
             <a:endParaRPr lang="en-US" sz="1100" dirty="0"/>
           </a:p>
@@ -4317,7 +4406,7 @@
                 <a:ea typeface="Calibri" pitchFamily="34" charset="-122"/>
                 <a:cs typeface="Calibri" pitchFamily="34" charset="-120"/>
               </a:rPr>
-              <a:t>13 / 13</a:t>
+              <a:t>13 / 14</a:t>
             </a:r>
             <a:endParaRPr lang="en-US" sz="2800" dirty="0"/>
           </a:p>
@@ -4376,7 +4465,967 @@
                 <a:ea typeface="Calibri" pitchFamily="34" charset="-122"/>
                 <a:cs typeface="Calibri" pitchFamily="34" charset="-120"/>
               </a:rPr>
-              <a:t>SLIDE 13 / 13   |   BENCHMARK</a:t>
+              <a:t>SLIDE 13 / 14   |   SCALE</a:t>
+            </a:r>
+            <a:endParaRPr lang="en-US" sz="1100" dirty="0"/>
+          </a:p>
+        </p:txBody>
+      </p:sp>
+      <p:sp>
+        <p:nvSpPr>
+          <p:cNvPr id="6" name="Text 4"/>
+          <p:cNvSpPr/>
+          <p:nvPr/>
+        </p:nvSpPr>
+        <p:spPr>
+          <a:xfrm>
+            <a:off x="548640" y="594360"/>
+            <a:ext cx="11064240" cy="685800"/>
+          </a:xfrm>
+          <a:prstGeom prst="rect">
+            <a:avLst/>
+          </a:prstGeom>
+          <a:noFill/>
+          <a:ln/>
+        </p:spPr>
+        <p:txBody>
+          <a:bodyPr wrap="square" lIns="0" tIns="0" rIns="0" bIns="0" rtlCol="0" anchor="ctr"/>
+          <a:lstStyle/>
+          <a:p>
+            <a:pPr indent="0" marL="0">
+              <a:buNone/>
+            </a:pPr>
+            <a:r>
+              <a:rPr lang="en-US" sz="3200" b="1" dirty="0">
+                <a:solidFill>
+                  <a:srgbClr val="F5F7FF"/>
+                </a:solidFill>
+                <a:latin typeface="Calibri" pitchFamily="34" charset="0"/>
+                <a:ea typeface="Calibri" pitchFamily="34" charset="-122"/>
+                <a:cs typeface="Calibri" pitchFamily="34" charset="-120"/>
+              </a:rPr>
+              <a:t>Why quantum: what changes at 1000 qubits (500 antennas)</a:t>
+            </a:r>
+            <a:endParaRPr lang="en-US" sz="3200" dirty="0"/>
+          </a:p>
+        </p:txBody>
+      </p:sp>
+      <p:sp>
+        <p:nvSpPr>
+          <p:cNvPr id="7" name="Text 5"/>
+          <p:cNvSpPr/>
+          <p:nvPr/>
+        </p:nvSpPr>
+        <p:spPr>
+          <a:xfrm>
+            <a:off x="548640" y="6446520"/>
+            <a:ext cx="7315200" cy="274320"/>
+          </a:xfrm>
+          <a:prstGeom prst="rect">
+            <a:avLst/>
+          </a:prstGeom>
+          <a:noFill/>
+          <a:ln/>
+        </p:spPr>
+        <p:txBody>
+          <a:bodyPr wrap="square" lIns="0" tIns="0" rIns="0" bIns="0" rtlCol="0" anchor="ctr"/>
+          <a:lstStyle/>
+          <a:p>
+            <a:pPr indent="0" marL="0">
+              <a:buNone/>
+            </a:pPr>
+            <a:r>
+              <a:rPr lang="en-US" sz="1000" dirty="0">
+                <a:solidFill>
+                  <a:srgbClr val="A9B4D0"/>
+                </a:solidFill>
+                <a:latin typeface="Calibri" pitchFamily="34" charset="0"/>
+                <a:ea typeface="Calibri" pitchFamily="34" charset="-122"/>
+                <a:cs typeface="Calibri" pitchFamily="34" charset="-120"/>
+              </a:rPr>
+              <a:t>Quantum Headache · QUBIT 2026 · Antenna Tilt</a:t>
+            </a:r>
+            <a:endParaRPr lang="en-US" sz="1000" dirty="0"/>
+          </a:p>
+        </p:txBody>
+      </p:sp>
+      <p:sp>
+        <p:nvSpPr>
+          <p:cNvPr id="8" name="Shape 6"/>
+          <p:cNvSpPr/>
+          <p:nvPr/>
+        </p:nvSpPr>
+        <p:spPr>
+          <a:xfrm>
+            <a:off x="548640" y="1463040"/>
+            <a:ext cx="3611880" cy="1234440"/>
+          </a:xfrm>
+          <a:prstGeom prst="roundRect">
+            <a:avLst>
+              <a:gd name="adj" fmla="val 5926"/>
+            </a:avLst>
+          </a:prstGeom>
+          <a:solidFill>
+            <a:srgbClr val="141B33"/>
+          </a:solidFill>
+          <a:ln w="12700">
+            <a:solidFill>
+              <a:srgbClr val="141B33"/>
+            </a:solidFill>
+            <a:prstDash val="solid"/>
+          </a:ln>
+        </p:spPr>
+      </p:sp>
+      <p:sp>
+        <p:nvSpPr>
+          <p:cNvPr id="9" name="Text 7"/>
+          <p:cNvSpPr/>
+          <p:nvPr/>
+        </p:nvSpPr>
+        <p:spPr>
+          <a:xfrm>
+            <a:off x="548640" y="1572768"/>
+            <a:ext cx="3611880" cy="640080"/>
+          </a:xfrm>
+          <a:prstGeom prst="rect">
+            <a:avLst/>
+          </a:prstGeom>
+          <a:noFill/>
+          <a:ln/>
+        </p:spPr>
+        <p:txBody>
+          <a:bodyPr wrap="square" lIns="0" tIns="0" rIns="0" bIns="0" rtlCol="0" anchor="ctr"/>
+          <a:lstStyle/>
+          <a:p>
+            <a:pPr algn="ctr" indent="0" marL="0">
+              <a:buNone/>
+            </a:pPr>
+            <a:r>
+              <a:rPr lang="en-US" sz="3000" b="1" dirty="0">
+                <a:solidFill>
+                  <a:srgbClr val="2BD4C2"/>
+                </a:solidFill>
+                <a:latin typeface="Calibri" pitchFamily="34" charset="0"/>
+                <a:ea typeface="Calibri" pitchFamily="34" charset="-122"/>
+                <a:cs typeface="Calibri" pitchFamily="34" charset="-120"/>
+              </a:rPr>
+              <a:t>2¹⁰⁰⁰ ≈ 10³⁰¹</a:t>
+            </a:r>
+            <a:endParaRPr lang="en-US" sz="3000" dirty="0"/>
+          </a:p>
+        </p:txBody>
+      </p:sp>
+      <p:sp>
+        <p:nvSpPr>
+          <p:cNvPr id="10" name="Text 8"/>
+          <p:cNvSpPr/>
+          <p:nvPr/>
+        </p:nvSpPr>
+        <p:spPr>
+          <a:xfrm>
+            <a:off x="640080" y="2194560"/>
+            <a:ext cx="3429000" cy="457200"/>
+          </a:xfrm>
+          <a:prstGeom prst="rect">
+            <a:avLst/>
+          </a:prstGeom>
+          <a:noFill/>
+          <a:ln/>
+        </p:spPr>
+        <p:txBody>
+          <a:bodyPr wrap="square" lIns="0" tIns="0" rIns="0" bIns="0" rtlCol="0" anchor="ctr"/>
+          <a:lstStyle/>
+          <a:p>
+            <a:pPr algn="ctr" indent="0" marL="0">
+              <a:buNone/>
+            </a:pPr>
+            <a:r>
+              <a:rPr lang="en-US" sz="1100" dirty="0">
+                <a:solidFill>
+                  <a:srgbClr val="A9B4D0"/>
+                </a:solidFill>
+                <a:latin typeface="Calibri" pitchFamily="34" charset="0"/>
+                <a:ea typeface="Calibri" pitchFamily="34" charset="-122"/>
+                <a:cs typeface="Calibri" pitchFamily="34" charset="-120"/>
+              </a:rPr>
+              <a:t>plans for 500 antennas × 4 tilts (today: 4096)</a:t>
+            </a:r>
+            <a:endParaRPr lang="en-US" sz="1100" dirty="0"/>
+          </a:p>
+        </p:txBody>
+      </p:sp>
+      <p:sp>
+        <p:nvSpPr>
+          <p:cNvPr id="11" name="Shape 9"/>
+          <p:cNvSpPr/>
+          <p:nvPr/>
+        </p:nvSpPr>
+        <p:spPr>
+          <a:xfrm>
+            <a:off x="4297680" y="1463040"/>
+            <a:ext cx="3611880" cy="1234440"/>
+          </a:xfrm>
+          <a:prstGeom prst="roundRect">
+            <a:avLst>
+              <a:gd name="adj" fmla="val 5926"/>
+            </a:avLst>
+          </a:prstGeom>
+          <a:solidFill>
+            <a:srgbClr val="141B33"/>
+          </a:solidFill>
+          <a:ln w="12700">
+            <a:solidFill>
+              <a:srgbClr val="141B33"/>
+            </a:solidFill>
+            <a:prstDash val="solid"/>
+          </a:ln>
+        </p:spPr>
+      </p:sp>
+      <p:sp>
+        <p:nvSpPr>
+          <p:cNvPr id="12" name="Text 10"/>
+          <p:cNvSpPr/>
+          <p:nvPr/>
+        </p:nvSpPr>
+        <p:spPr>
+          <a:xfrm>
+            <a:off x="4297680" y="1572768"/>
+            <a:ext cx="3611880" cy="640080"/>
+          </a:xfrm>
+          <a:prstGeom prst="rect">
+            <a:avLst/>
+          </a:prstGeom>
+          <a:noFill/>
+          <a:ln/>
+        </p:spPr>
+        <p:txBody>
+          <a:bodyPr wrap="square" lIns="0" tIns="0" rIns="0" bIns="0" rtlCol="0" anchor="ctr"/>
+          <a:lstStyle/>
+          <a:p>
+            <a:pPr algn="ctr" indent="0" marL="0">
+              <a:buNone/>
+            </a:pPr>
+            <a:r>
+              <a:rPr lang="en-US" sz="3000" b="1" dirty="0">
+                <a:solidFill>
+                  <a:srgbClr val="FFB454"/>
+                </a:solidFill>
+                <a:latin typeface="Calibri" pitchFamily="34" charset="0"/>
+                <a:ea typeface="Calibri" pitchFamily="34" charset="-122"/>
+                <a:cs typeface="Calibri" pitchFamily="34" charset="-120"/>
+              </a:rPr>
+              <a:t>≈ 45 qubits</a:t>
+            </a:r>
+            <a:endParaRPr lang="en-US" sz="3000" dirty="0"/>
+          </a:p>
+        </p:txBody>
+      </p:sp>
+      <p:sp>
+        <p:nvSpPr>
+          <p:cNvPr id="13" name="Text 11"/>
+          <p:cNvSpPr/>
+          <p:nvPr/>
+        </p:nvSpPr>
+        <p:spPr>
+          <a:xfrm>
+            <a:off x="4389120" y="2194560"/>
+            <a:ext cx="3429000" cy="457200"/>
+          </a:xfrm>
+          <a:prstGeom prst="rect">
+            <a:avLst/>
+          </a:prstGeom>
+          <a:noFill/>
+          <a:ln/>
+        </p:spPr>
+        <p:txBody>
+          <a:bodyPr wrap="square" lIns="0" tIns="0" rIns="0" bIns="0" rtlCol="0" anchor="ctr"/>
+          <a:lstStyle/>
+          <a:p>
+            <a:pPr algn="ctr" indent="0" marL="0">
+              <a:buNone/>
+            </a:pPr>
+            <a:r>
+              <a:rPr lang="en-US" sz="1100" dirty="0">
+                <a:solidFill>
+                  <a:srgbClr val="A9B4D0"/>
+                </a:solidFill>
+                <a:latin typeface="Calibri" pitchFamily="34" charset="0"/>
+                <a:ea typeface="Calibri" pitchFamily="34" charset="-122"/>
+                <a:cs typeface="Calibri" pitchFamily="34" charset="-120"/>
+              </a:rPr>
+              <a:t>ceiling of exact statevector simulation: 50 q = 18 PB &gt; Frontier 9 PB</a:t>
+            </a:r>
+            <a:endParaRPr lang="en-US" sz="1100" dirty="0"/>
+          </a:p>
+        </p:txBody>
+      </p:sp>
+      <p:sp>
+        <p:nvSpPr>
+          <p:cNvPr id="14" name="Shape 12"/>
+          <p:cNvSpPr/>
+          <p:nvPr/>
+        </p:nvSpPr>
+        <p:spPr>
+          <a:xfrm>
+            <a:off x="8046720" y="1463040"/>
+            <a:ext cx="3749040" cy="1234440"/>
+          </a:xfrm>
+          <a:prstGeom prst="roundRect">
+            <a:avLst>
+              <a:gd name="adj" fmla="val 5926"/>
+            </a:avLst>
+          </a:prstGeom>
+          <a:solidFill>
+            <a:srgbClr val="141B33"/>
+          </a:solidFill>
+          <a:ln w="12700">
+            <a:solidFill>
+              <a:srgbClr val="141B33"/>
+            </a:solidFill>
+            <a:prstDash val="solid"/>
+          </a:ln>
+        </p:spPr>
+      </p:sp>
+      <p:sp>
+        <p:nvSpPr>
+          <p:cNvPr id="15" name="Text 13"/>
+          <p:cNvSpPr/>
+          <p:nvPr/>
+        </p:nvSpPr>
+        <p:spPr>
+          <a:xfrm>
+            <a:off x="8046720" y="1572768"/>
+            <a:ext cx="3749040" cy="640080"/>
+          </a:xfrm>
+          <a:prstGeom prst="rect">
+            <a:avLst/>
+          </a:prstGeom>
+          <a:noFill/>
+          <a:ln/>
+        </p:spPr>
+        <p:txBody>
+          <a:bodyPr wrap="square" lIns="0" tIns="0" rIns="0" bIns="0" rtlCol="0" anchor="ctr"/>
+          <a:lstStyle/>
+          <a:p>
+            <a:pPr algn="ctr" indent="0" marL="0">
+              <a:buNone/>
+            </a:pPr>
+            <a:r>
+              <a:rPr lang="en-US" sz="3000" b="1" dirty="0">
+                <a:solidFill>
+                  <a:srgbClr val="2BD4C2"/>
+                </a:solidFill>
+                <a:latin typeface="Calibri" pitchFamily="34" charset="0"/>
+                <a:ea typeface="Calibri" pitchFamily="34" charset="-122"/>
+                <a:cs typeface="Calibri" pitchFamily="34" charset="-120"/>
+              </a:rPr>
+              <a:t>≈ 13 000 CX</a:t>
+            </a:r>
+            <a:endParaRPr lang="en-US" sz="3000" dirty="0"/>
+          </a:p>
+        </p:txBody>
+      </p:sp>
+      <p:sp>
+        <p:nvSpPr>
+          <p:cNvPr id="16" name="Text 14"/>
+          <p:cNvSpPr/>
+          <p:nvPr/>
+        </p:nvSpPr>
+        <p:spPr>
+          <a:xfrm>
+            <a:off x="8138160" y="2194560"/>
+            <a:ext cx="3566160" cy="457200"/>
+          </a:xfrm>
+          <a:prstGeom prst="rect">
+            <a:avLst/>
+          </a:prstGeom>
+          <a:noFill/>
+          <a:ln/>
+        </p:spPr>
+        <p:txBody>
+          <a:bodyPr wrap="square" lIns="0" tIns="0" rIns="0" bIns="0" rtlCol="0" anchor="ctr"/>
+          <a:lstStyle/>
+          <a:p>
+            <a:pPr algn="ctr" indent="0" marL="0">
+              <a:buNone/>
+            </a:pPr>
+            <a:r>
+              <a:rPr lang="en-US" sz="1100" dirty="0">
+                <a:solidFill>
+                  <a:srgbClr val="A9B4D0"/>
+                </a:solidFill>
+                <a:latin typeface="Calibri" pitchFamily="34" charset="0"/>
+                <a:ea typeface="Calibri" pitchFamily="34" charset="-122"/>
+                <a:cs typeface="Calibri" pitchFamily="34" charset="-120"/>
+              </a:rPr>
+              <a:t>one QAOA layer at 1000 q: 2-local, local coupling, depth ~10²</a:t>
+            </a:r>
+            <a:endParaRPr lang="en-US" sz="1100" dirty="0"/>
+          </a:p>
+        </p:txBody>
+      </p:sp>
+      <p:sp>
+        <p:nvSpPr>
+          <p:cNvPr id="17" name="Shape 15"/>
+          <p:cNvSpPr/>
+          <p:nvPr/>
+        </p:nvSpPr>
+        <p:spPr>
+          <a:xfrm>
+            <a:off x="548640" y="2834640"/>
+            <a:ext cx="5532120" cy="2697480"/>
+          </a:xfrm>
+          <a:prstGeom prst="roundRect">
+            <a:avLst>
+              <a:gd name="adj" fmla="val 2712"/>
+            </a:avLst>
+          </a:prstGeom>
+          <a:solidFill>
+            <a:srgbClr val="141B33"/>
+          </a:solidFill>
+          <a:ln w="12700">
+            <a:solidFill>
+              <a:srgbClr val="141B33"/>
+            </a:solidFill>
+            <a:prstDash val="solid"/>
+          </a:ln>
+        </p:spPr>
+      </p:sp>
+      <p:sp>
+        <p:nvSpPr>
+          <p:cNvPr id="18" name="Text 16"/>
+          <p:cNvSpPr/>
+          <p:nvPr/>
+        </p:nvSpPr>
+        <p:spPr>
+          <a:xfrm>
+            <a:off x="685800" y="2880360"/>
+            <a:ext cx="5303520" cy="320040"/>
+          </a:xfrm>
+          <a:prstGeom prst="rect">
+            <a:avLst/>
+          </a:prstGeom>
+          <a:noFill/>
+          <a:ln/>
+        </p:spPr>
+        <p:txBody>
+          <a:bodyPr wrap="square" lIns="0" tIns="0" rIns="0" bIns="0" rtlCol="0" anchor="ctr"/>
+          <a:lstStyle/>
+          <a:p>
+            <a:pPr indent="0" marL="0">
+              <a:buNone/>
+            </a:pPr>
+            <a:r>
+              <a:rPr lang="en-US" sz="1400" b="1" dirty="0">
+                <a:solidFill>
+                  <a:srgbClr val="FF5C7A"/>
+                </a:solidFill>
+                <a:latin typeface="Calibri" pitchFamily="34" charset="0"/>
+                <a:ea typeface="Calibri" pitchFamily="34" charset="-122"/>
+                <a:cs typeface="Calibri" pitchFamily="34" charset="-120"/>
+              </a:rPr>
+              <a:t>Best non-quantum tools on this size</a:t>
+            </a:r>
+            <a:endParaRPr lang="en-US" sz="1400" dirty="0"/>
+          </a:p>
+        </p:txBody>
+      </p:sp>
+      <p:sp>
+        <p:nvSpPr>
+          <p:cNvPr id="19" name="Text 17"/>
+          <p:cNvSpPr/>
+          <p:nvPr/>
+        </p:nvSpPr>
+        <p:spPr>
+          <a:xfrm>
+            <a:off x="640080" y="3200400"/>
+            <a:ext cx="5394960" cy="2286000"/>
+          </a:xfrm>
+          <a:prstGeom prst="rect">
+            <a:avLst/>
+          </a:prstGeom>
+          <a:noFill/>
+          <a:ln/>
+        </p:spPr>
+        <p:txBody>
+          <a:bodyPr wrap="square" lIns="635" tIns="635" rIns="635" bIns="635" rtlCol="0" anchor="t"/>
+          <a:lstStyle/>
+          <a:p>
+            <a:pPr marL="342900" indent="-342900">
+              <a:spcAft>
+                <a:spcPts val="600"/>
+              </a:spcAft>
+              <a:buSzPct val="100000"/>
+              <a:buChar char="▸"/>
+            </a:pPr>
+            <a:r>
+              <a:rPr lang="en-US" sz="1100" dirty="0">
+                <a:solidFill>
+                  <a:srgbClr val="F5F7FF"/>
+                </a:solidFill>
+                <a:latin typeface="Calibri" pitchFamily="34" charset="0"/>
+                <a:ea typeface="Calibri" pitchFamily="34" charset="-122"/>
+                <a:cs typeface="Calibri" pitchFamily="34" charset="-120"/>
+              </a:rPr>
+              <a:t>Brute force (our exact check today): 10³⁰¹ plans at 10¹⁸ / s (exascale) = 10²⁸³ s; the universe is 4×10¹⁷ s old</a:t>
+            </a:r>
+            <a:endParaRPr lang="en-US" sz="1100" dirty="0"/>
+          </a:p>
+          <a:p>
+            <a:pPr marL="342900" indent="-342900">
+              <a:spcAft>
+                <a:spcPts val="600"/>
+              </a:spcAft>
+              <a:buSzPct val="100000"/>
+              <a:buChar char="▸"/>
+            </a:pPr>
+            <a:r>
+              <a:rPr lang="en-US" sz="1100" dirty="0">
+                <a:solidFill>
+                  <a:srgbClr val="F5F7FF"/>
+                </a:solidFill>
+                <a:latin typeface="Calibri" pitchFamily="34" charset="0"/>
+                <a:ea typeface="Calibri" pitchFamily="34" charset="-122"/>
+                <a:cs typeface="Calibri" pitchFamily="34" charset="-120"/>
+              </a:rPr>
+              <a:t>Exact simulation of the quantum algorithm (Wolfram / Classiq simulator): memory 2ⁿ × 16 B, 45 q = 0.5 PB, 50 q = 18 PB. Nobody can simulate QAOA past ≈ 48 qubits</a:t>
+            </a:r>
+            <a:endParaRPr lang="en-US" sz="1100" dirty="0"/>
+          </a:p>
+          <a:p>
+            <a:pPr marL="342900" indent="-342900">
+              <a:spcAft>
+                <a:spcPts val="600"/>
+              </a:spcAft>
+              <a:buSzPct val="100000"/>
+              <a:buChar char="▸"/>
+            </a:pPr>
+            <a:r>
+              <a:rPr lang="en-US" sz="1100" dirty="0">
+                <a:solidFill>
+                  <a:srgbClr val="F5F7FF"/>
+                </a:solidFill>
+                <a:latin typeface="Calibri" pitchFamily="34" charset="0"/>
+                <a:ea typeface="Calibri" pitchFamily="34" charset="-122"/>
+                <a:cs typeface="Calibri" pitchFamily="34" charset="-120"/>
+              </a:rPr>
+              <a:t>Exact QUBO solvers (branch &amp; bound, Gurobi): sparse 1000-variable instances run hours to days and may never certify the optimum</a:t>
+            </a:r>
+            <a:endParaRPr lang="en-US" sz="1100" dirty="0"/>
+          </a:p>
+          <a:p>
+            <a:pPr marL="342900" indent="-342900">
+              <a:spcAft>
+                <a:spcPts val="600"/>
+              </a:spcAft>
+              <a:buSzPct val="100000"/>
+              <a:buChar char="▸"/>
+            </a:pPr>
+            <a:r>
+              <a:rPr lang="en-US" sz="1100" dirty="0">
+                <a:solidFill>
+                  <a:srgbClr val="F5F7FF"/>
+                </a:solidFill>
+                <a:latin typeface="Calibri" pitchFamily="34" charset="0"/>
+                <a:ea typeface="Calibri" pitchFamily="34" charset="-122"/>
+                <a:cs typeface="Calibri" pitchFamily="34" charset="-120"/>
+              </a:rPr>
+              <a:t>Heuristics (simulated annealing, tabu, D-Wave 4 400-qubit annealer): minutes, good plan, no guarantee. This is the real competitor (1.833 vs 1.838 on the toy benchmark)</a:t>
+            </a:r>
+            <a:endParaRPr lang="en-US" sz="1100" dirty="0"/>
+          </a:p>
+        </p:txBody>
+      </p:sp>
+      <p:sp>
+        <p:nvSpPr>
+          <p:cNvPr id="20" name="Shape 18"/>
+          <p:cNvSpPr/>
+          <p:nvPr/>
+        </p:nvSpPr>
+        <p:spPr>
+          <a:xfrm>
+            <a:off x="6263640" y="2834640"/>
+            <a:ext cx="5532120" cy="2697480"/>
+          </a:xfrm>
+          <a:prstGeom prst="roundRect">
+            <a:avLst>
+              <a:gd name="adj" fmla="val 2712"/>
+            </a:avLst>
+          </a:prstGeom>
+          <a:solidFill>
+            <a:srgbClr val="141B33"/>
+          </a:solidFill>
+          <a:ln w="12700">
+            <a:solidFill>
+              <a:srgbClr val="141B33"/>
+            </a:solidFill>
+            <a:prstDash val="solid"/>
+          </a:ln>
+        </p:spPr>
+      </p:sp>
+      <p:sp>
+        <p:nvSpPr>
+          <p:cNvPr id="21" name="Text 19"/>
+          <p:cNvSpPr/>
+          <p:nvPr/>
+        </p:nvSpPr>
+        <p:spPr>
+          <a:xfrm>
+            <a:off x="6400800" y="2880360"/>
+            <a:ext cx="5303520" cy="320040"/>
+          </a:xfrm>
+          <a:prstGeom prst="rect">
+            <a:avLst/>
+          </a:prstGeom>
+          <a:noFill/>
+          <a:ln/>
+        </p:spPr>
+        <p:txBody>
+          <a:bodyPr wrap="square" lIns="0" tIns="0" rIns="0" bIns="0" rtlCol="0" anchor="ctr"/>
+          <a:lstStyle/>
+          <a:p>
+            <a:pPr indent="0" marL="0">
+              <a:buNone/>
+            </a:pPr>
+            <a:r>
+              <a:rPr lang="en-US" sz="1400" b="1" dirty="0">
+                <a:solidFill>
+                  <a:srgbClr val="2BD4C2"/>
+                </a:solidFill>
+                <a:latin typeface="Calibri" pitchFamily="34" charset="0"/>
+                <a:ea typeface="Calibri" pitchFamily="34" charset="-122"/>
+                <a:cs typeface="Calibri" pitchFamily="34" charset="-120"/>
+              </a:rPr>
+              <a:t>A real 1000-qubit gate-based quantum computer</a:t>
+            </a:r>
+            <a:endParaRPr lang="en-US" sz="1400" dirty="0"/>
+          </a:p>
+        </p:txBody>
+      </p:sp>
+      <p:sp>
+        <p:nvSpPr>
+          <p:cNvPr id="22" name="Text 20"/>
+          <p:cNvSpPr/>
+          <p:nvPr/>
+        </p:nvSpPr>
+        <p:spPr>
+          <a:xfrm>
+            <a:off x="6355080" y="3200400"/>
+            <a:ext cx="5394960" cy="2286000"/>
+          </a:xfrm>
+          <a:prstGeom prst="rect">
+            <a:avLst/>
+          </a:prstGeom>
+          <a:noFill/>
+          <a:ln/>
+        </p:spPr>
+        <p:txBody>
+          <a:bodyPr wrap="square" lIns="635" tIns="635" rIns="635" bIns="635" rtlCol="0" anchor="t"/>
+          <a:lstStyle/>
+          <a:p>
+            <a:pPr marL="342900" indent="-342900">
+              <a:spcAft>
+                <a:spcPts val="600"/>
+              </a:spcAft>
+              <a:buSzPct val="100000"/>
+              <a:buChar char="▸"/>
+            </a:pPr>
+            <a:r>
+              <a:rPr lang="en-US" sz="1100" dirty="0">
+                <a:solidFill>
+                  <a:srgbClr val="F5F7FF"/>
+                </a:solidFill>
+                <a:latin typeface="Calibri" pitchFamily="34" charset="0"/>
+                <a:ea typeface="Calibri" pitchFamily="34" charset="-122"/>
+                <a:cs typeface="Calibri" pitchFamily="34" charset="-120"/>
+              </a:rPr>
+              <a:t>Physical qubits exist (Sep 2026): IBM Condor 1 121, Atom Computing 1 200, Infleqtion 1 600; best 2-qubit fidelity 99.92% (Quantinuum Helios, 98 q)</a:t>
+            </a:r>
+            <a:endParaRPr lang="en-US" sz="1100" dirty="0"/>
+          </a:p>
+          <a:p>
+            <a:pPr marL="342900" indent="-342900">
+              <a:spcAft>
+                <a:spcPts val="600"/>
+              </a:spcAft>
+              <a:buSzPct val="100000"/>
+              <a:buChar char="▸"/>
+            </a:pPr>
+            <a:r>
+              <a:rPr lang="en-US" sz="1100" dirty="0">
+                <a:solidFill>
+                  <a:srgbClr val="F5F7FF"/>
+                </a:solidFill>
+                <a:latin typeface="Calibri" pitchFamily="34" charset="0"/>
+                <a:ea typeface="Calibri" pitchFamily="34" charset="-122"/>
+                <a:cs typeface="Calibri" pitchFamily="34" charset="-120"/>
+              </a:rPr>
+              <a:t>13 000 CX at 99.9% = ≈ 13 errors per shot, so the run must be error-corrected: 1000 logical qubits = 2 000 (2:1 colour code) to 100 000 (surface code) physical. Record today: 96 logical (QuEra). Roadmaps: 2028–2030</a:t>
+            </a:r>
+            <a:endParaRPr lang="en-US" sz="1100" dirty="0"/>
+          </a:p>
+          <a:p>
+            <a:pPr marL="342900" indent="-342900">
+              <a:spcAft>
+                <a:spcPts val="600"/>
+              </a:spcAft>
+              <a:buSzPct val="100000"/>
+              <a:buChar char="▸"/>
+            </a:pPr>
+            <a:r>
+              <a:rPr lang="en-US" sz="1100" dirty="0">
+                <a:solidFill>
+                  <a:srgbClr val="F5F7FF"/>
+                </a:solidFill>
+                <a:latin typeface="Calibri" pitchFamily="34" charset="0"/>
+                <a:ea typeface="Calibri" pitchFamily="34" charset="-122"/>
+                <a:cs typeface="Calibri" pitchFamily="34" charset="-120"/>
+              </a:rPr>
+              <a:t>Runtime once available: depth ~10² per layer, 1 shot ≈ 0.1 ms (superconducting) to 10 ms (ions); 10⁴ shots × 20 iterations = seconds to minutes; Wolfram warm start cuts the iterations</a:t>
+            </a:r>
+            <a:endParaRPr lang="en-US" sz="1100" dirty="0"/>
+          </a:p>
+          <a:p>
+            <a:pPr marL="342900" indent="-342900">
+              <a:spcAft>
+                <a:spcPts val="600"/>
+              </a:spcAft>
+              <a:buSzPct val="100000"/>
+              <a:buChar char="▸"/>
+            </a:pPr>
+            <a:r>
+              <a:rPr lang="en-US" sz="1100" dirty="0">
+                <a:solidFill>
+                  <a:srgbClr val="F5F7FF"/>
+                </a:solidFill>
+                <a:latin typeface="Calibri" pitchFamily="34" charset="0"/>
+                <a:ea typeface="Calibri" pitchFamily="34" charset="-122"/>
+                <a:cs typeface="Calibri" pitchFamily="34" charset="-120"/>
+              </a:rPr>
+              <a:t>Same Qmod program: Classiq synthesises for the target, simulator today, hardware backend tomorrow. No code change but the backend</a:t>
+            </a:r>
+            <a:endParaRPr lang="en-US" sz="1100" dirty="0"/>
+          </a:p>
+        </p:txBody>
+      </p:sp>
+      <p:sp>
+        <p:nvSpPr>
+          <p:cNvPr id="23" name="Shape 21"/>
+          <p:cNvSpPr/>
+          <p:nvPr/>
+        </p:nvSpPr>
+        <p:spPr>
+          <a:xfrm>
+            <a:off x="548640" y="5623560"/>
+            <a:ext cx="9692640" cy="685800"/>
+          </a:xfrm>
+          <a:prstGeom prst="roundRect">
+            <a:avLst>
+              <a:gd name="adj" fmla="val 8000"/>
+            </a:avLst>
+          </a:prstGeom>
+          <a:solidFill>
+            <a:srgbClr val="7C5CFF"/>
+          </a:solidFill>
+          <a:ln w="12700">
+            <a:solidFill>
+              <a:srgbClr val="7C5CFF"/>
+            </a:solidFill>
+            <a:prstDash val="solid"/>
+          </a:ln>
+        </p:spPr>
+      </p:sp>
+      <p:sp>
+        <p:nvSpPr>
+          <p:cNvPr id="24" name="Text 22"/>
+          <p:cNvSpPr/>
+          <p:nvPr/>
+        </p:nvSpPr>
+        <p:spPr>
+          <a:xfrm>
+            <a:off x="640080" y="5623560"/>
+            <a:ext cx="9509760" cy="685800"/>
+          </a:xfrm>
+          <a:prstGeom prst="rect">
+            <a:avLst/>
+          </a:prstGeom>
+          <a:noFill/>
+          <a:ln/>
+        </p:spPr>
+        <p:txBody>
+          <a:bodyPr wrap="square" lIns="381" tIns="381" rIns="381" bIns="381" rtlCol="0" anchor="ctr"/>
+          <a:lstStyle/>
+          <a:p>
+            <a:pPr indent="0" marL="0">
+              <a:buNone/>
+            </a:pPr>
+            <a:r>
+              <a:rPr lang="en-US" sz="1100" dirty="0">
+                <a:solidFill>
+                  <a:srgbClr val="F5F7FF"/>
+                </a:solidFill>
+                <a:latin typeface="Calibri" pitchFamily="34" charset="0"/>
+                <a:ea typeface="Calibri" pitchFamily="34" charset="-122"/>
+                <a:cs typeface="Calibri" pitchFamily="34" charset="-120"/>
+              </a:rPr>
+              <a:t>Classical tools give a good plan and stop there. At 12 qubits we measured 27× amplification and P(cost&lt;0) 2.4% → 53% → 67% with p; whether that persists at 1000 qubits cannot be checked classically. The only instrument that can run the algorithm at this size is the quantum computer itself.</a:t>
+            </a:r>
+            <a:endParaRPr lang="en-US" sz="1100" dirty="0"/>
+          </a:p>
+        </p:txBody>
+      </p:sp>
+    </p:spTree>
+  </p:cSld>
+  <p:clrMapOvr>
+    <a:masterClrMapping/>
+  </p:clrMapOvr>
+</p:sld>
+</file>
+
+<file path=ppt/slides/slide14.xml><?xml version="1.0" encoding="utf-8"?>
+<p:sld xmlns:a="http://schemas.openxmlformats.org/drawingml/2006/main" xmlns:r="http://schemas.openxmlformats.org/officeDocument/2006/relationships" xmlns:p="http://schemas.openxmlformats.org/presentationml/2006/main">
+  <p:cSld name="Slide 14">
+    <p:bg>
+      <p:bgPr>
+        <a:solidFill>
+          <a:srgbClr val="0B1020"/>
+        </a:solidFill>
+      </p:bgPr>
+    </p:bg>
+    <p:spTree>
+      <p:nvGrpSpPr>
+        <p:cNvPr id="1" name=""/>
+        <p:cNvGrpSpPr/>
+        <p:nvPr/>
+      </p:nvGrpSpPr>
+      <p:grpSpPr>
+        <a:xfrm>
+          <a:off x="0" y="0"/>
+          <a:ext cx="0" cy="0"/>
+          <a:chOff x="0" y="0"/>
+          <a:chExt cx="0" cy="0"/>
+        </a:xfrm>
+      </p:grpSpPr>
+      <p:sp>
+        <p:nvSpPr>
+          <p:cNvPr id="2" name="Shape 0"/>
+          <p:cNvSpPr/>
+          <p:nvPr/>
+        </p:nvSpPr>
+        <p:spPr>
+          <a:xfrm>
+            <a:off x="10378440" y="6035040"/>
+            <a:ext cx="1600200" cy="640080"/>
+          </a:xfrm>
+          <a:prstGeom prst="roundRect">
+            <a:avLst>
+              <a:gd name="adj" fmla="val 14286"/>
+            </a:avLst>
+          </a:prstGeom>
+          <a:solidFill>
+            <a:srgbClr val="7C5CFF"/>
+          </a:solidFill>
+          <a:ln w="12700">
+            <a:solidFill>
+              <a:srgbClr val="7C5CFF"/>
+            </a:solidFill>
+            <a:prstDash val="solid"/>
+          </a:ln>
+        </p:spPr>
+      </p:sp>
+      <p:sp>
+        <p:nvSpPr>
+          <p:cNvPr id="3" name="Text 1"/>
+          <p:cNvSpPr/>
+          <p:nvPr/>
+        </p:nvSpPr>
+        <p:spPr>
+          <a:xfrm>
+            <a:off x="10378440" y="6035040"/>
+            <a:ext cx="1600200" cy="640080"/>
+          </a:xfrm>
+          <a:prstGeom prst="rect">
+            <a:avLst/>
+          </a:prstGeom>
+          <a:noFill/>
+          <a:ln/>
+        </p:spPr>
+        <p:txBody>
+          <a:bodyPr wrap="square" lIns="0" tIns="0" rIns="0" bIns="0" rtlCol="0" anchor="ctr"/>
+          <a:lstStyle/>
+          <a:p>
+            <a:pPr algn="ctr" indent="0" marL="0">
+              <a:buNone/>
+            </a:pPr>
+            <a:r>
+              <a:rPr lang="en-US" sz="2800" b="1" dirty="0">
+                <a:solidFill>
+                  <a:srgbClr val="F5F7FF"/>
+                </a:solidFill>
+                <a:latin typeface="Calibri" pitchFamily="34" charset="0"/>
+                <a:ea typeface="Calibri" pitchFamily="34" charset="-122"/>
+                <a:cs typeface="Calibri" pitchFamily="34" charset="-120"/>
+              </a:rPr>
+              <a:t>14 / 14</a:t>
+            </a:r>
+            <a:endParaRPr lang="en-US" sz="2800" dirty="0"/>
+          </a:p>
+        </p:txBody>
+      </p:sp>
+      <p:sp>
+        <p:nvSpPr>
+          <p:cNvPr id="4" name="Shape 2"/>
+          <p:cNvSpPr/>
+          <p:nvPr/>
+        </p:nvSpPr>
+        <p:spPr>
+          <a:xfrm>
+            <a:off x="0" y="0"/>
+            <a:ext cx="164592" cy="6858000"/>
+          </a:xfrm>
+          <a:prstGeom prst="rect">
+            <a:avLst/>
+          </a:prstGeom>
+          <a:solidFill>
+            <a:srgbClr val="7C5CFF"/>
+          </a:solidFill>
+          <a:ln/>
+        </p:spPr>
+      </p:sp>
+      <p:sp>
+        <p:nvSpPr>
+          <p:cNvPr id="5" name="Text 3"/>
+          <p:cNvSpPr/>
+          <p:nvPr/>
+        </p:nvSpPr>
+        <p:spPr>
+          <a:xfrm>
+            <a:off x="548640" y="320040"/>
+            <a:ext cx="10972800" cy="274320"/>
+          </a:xfrm>
+          <a:prstGeom prst="rect">
+            <a:avLst/>
+          </a:prstGeom>
+          <a:noFill/>
+          <a:ln/>
+        </p:spPr>
+        <p:txBody>
+          <a:bodyPr wrap="square" lIns="0" tIns="0" rIns="0" bIns="0" rtlCol="0" anchor="ctr"/>
+          <a:lstStyle/>
+          <a:p>
+            <a:pPr indent="0" marL="0">
+              <a:buNone/>
+            </a:pPr>
+            <a:r>
+              <a:rPr lang="en-US" sz="1100" b="1" spc="200" kern="0" dirty="0">
+                <a:solidFill>
+                  <a:srgbClr val="2BD4C2"/>
+                </a:solidFill>
+                <a:latin typeface="Calibri" pitchFamily="34" charset="0"/>
+                <a:ea typeface="Calibri" pitchFamily="34" charset="-122"/>
+                <a:cs typeface="Calibri" pitchFamily="34" charset="-120"/>
+              </a:rPr>
+              <a:t>SLIDE 14 / 14   |   BENCHMARK</a:t>
             </a:r>
             <a:endParaRPr lang="en-US" sz="1100" dirty="0"/>
           </a:p>
@@ -5117,7 +6166,7 @@
                 <a:ea typeface="Calibri" pitchFamily="34" charset="-122"/>
                 <a:cs typeface="Calibri" pitchFamily="34" charset="-120"/>
               </a:rPr>
-              <a:t>2 / 13</a:t>
+              <a:t>2 / 14</a:t>
             </a:r>
             <a:endParaRPr lang="en-US" sz="2800" dirty="0"/>
           </a:p>
@@ -5176,7 +6225,7 @@
                 <a:ea typeface="Calibri" pitchFamily="34" charset="-122"/>
                 <a:cs typeface="Calibri" pitchFamily="34" charset="-120"/>
               </a:rPr>
-              <a:t>SLIDE 2 / 13   |   MOTIVATION</a:t>
+              <a:t>SLIDE 2 / 14   |   MOTIVATION</a:t>
             </a:r>
             <a:endParaRPr lang="en-US" sz="1100" dirty="0"/>
           </a:p>
@@ -5621,7 +6670,7 @@
                 <a:ea typeface="Calibri" pitchFamily="34" charset="-122"/>
                 <a:cs typeface="Calibri" pitchFamily="34" charset="-120"/>
               </a:rPr>
-              <a:t>3 / 13</a:t>
+              <a:t>3 / 14</a:t>
             </a:r>
             <a:endParaRPr lang="en-US" sz="2800" dirty="0"/>
           </a:p>
@@ -5680,7 +6729,7 @@
                 <a:ea typeface="Calibri" pitchFamily="34" charset="-122"/>
                 <a:cs typeface="Calibri" pitchFamily="34" charset="-120"/>
               </a:rPr>
-              <a:t>SLIDE 3 / 13   |   ARCHITECTURE</a:t>
+              <a:t>SLIDE 3 / 14   |   ARCHITECTURE</a:t>
             </a:r>
             <a:endParaRPr lang="en-US" sz="1100" dirty="0"/>
           </a:p>
@@ -6727,7 +7776,7 @@
                 <a:ea typeface="Calibri" pitchFamily="34" charset="-122"/>
                 <a:cs typeface="Calibri" pitchFamily="34" charset="-120"/>
               </a:rPr>
-              <a:t>4 / 13</a:t>
+              <a:t>4 / 14</a:t>
             </a:r>
             <a:endParaRPr lang="en-US" sz="2800" dirty="0"/>
           </a:p>
@@ -6786,7 +7835,7 @@
                 <a:ea typeface="Calibri" pitchFamily="34" charset="-122"/>
                 <a:cs typeface="Calibri" pitchFamily="34" charset="-120"/>
               </a:rPr>
-              <a:t>SLIDE 4 / 13   |   LEAF PROBLEM</a:t>
+              <a:t>SLIDE 4 / 14   |   LEAF PROBLEM</a:t>
             </a:r>
             <a:endParaRPr lang="en-US" sz="1100" dirty="0"/>
           </a:p>
@@ -7152,7 +8201,7 @@
                 <a:ea typeface="Calibri" pitchFamily="34" charset="-122"/>
                 <a:cs typeface="Calibri" pitchFamily="34" charset="-120"/>
               </a:rPr>
-              <a:t>5 / 13</a:t>
+              <a:t>5 / 14</a:t>
             </a:r>
             <a:endParaRPr lang="en-US" sz="2800" dirty="0"/>
           </a:p>
@@ -7211,7 +8260,7 @@
                 <a:ea typeface="Calibri" pitchFamily="34" charset="-122"/>
                 <a:cs typeface="Calibri" pitchFamily="34" charset="-120"/>
               </a:rPr>
-              <a:t>SLIDE 5 / 13   |   MODEL</a:t>
+              <a:t>SLIDE 5 / 14   |   MODEL</a:t>
             </a:r>
             <a:endParaRPr lang="en-US" sz="1100" dirty="0"/>
           </a:p>
@@ -7946,7 +8995,7 @@
                 <a:ea typeface="Calibri" pitchFamily="34" charset="-122"/>
                 <a:cs typeface="Calibri" pitchFamily="34" charset="-120"/>
               </a:rPr>
-              <a:t>6 / 13</a:t>
+              <a:t>6 / 14</a:t>
             </a:r>
             <a:endParaRPr lang="en-US" sz="2800" dirty="0"/>
           </a:p>
@@ -8005,7 +9054,7 @@
                 <a:ea typeface="Calibri" pitchFamily="34" charset="-122"/>
                 <a:cs typeface="Calibri" pitchFamily="34" charset="-120"/>
               </a:rPr>
-              <a:t>SLIDE 6 / 13   |   GATES</a:t>
+              <a:t>SLIDE 6 / 14   |   GATES</a:t>
             </a:r>
             <a:endParaRPr lang="en-US" sz="1100" dirty="0"/>
           </a:p>
@@ -8710,7 +9759,7 @@
                 <a:ea typeface="Calibri" pitchFamily="34" charset="-122"/>
                 <a:cs typeface="Calibri" pitchFamily="34" charset="-120"/>
               </a:rPr>
-              <a:t>7 / 13</a:t>
+              <a:t>7 / 14</a:t>
             </a:r>
             <a:endParaRPr lang="en-US" sz="2800" dirty="0"/>
           </a:p>
@@ -8769,7 +9818,7 @@
                 <a:ea typeface="Calibri" pitchFamily="34" charset="-122"/>
                 <a:cs typeface="Calibri" pitchFamily="34" charset="-120"/>
               </a:rPr>
-              <a:t>SLIDE 7 / 13   |   SIMULATION</a:t>
+              <a:t>SLIDE 7 / 14   |   SIMULATION</a:t>
             </a:r>
             <a:endParaRPr lang="en-US" sz="1100" dirty="0"/>
           </a:p>
@@ -9534,7 +10583,7 @@
                 <a:ea typeface="Calibri" pitchFamily="34" charset="-122"/>
                 <a:cs typeface="Calibri" pitchFamily="34" charset="-120"/>
               </a:rPr>
-              <a:t>8 / 13</a:t>
+              <a:t>8 / 14</a:t>
             </a:r>
             <a:endParaRPr lang="en-US" sz="2800" dirty="0"/>
           </a:p>
@@ -9593,7 +10642,7 @@
                 <a:ea typeface="Calibri" pitchFamily="34" charset="-122"/>
                 <a:cs typeface="Calibri" pitchFamily="34" charset="-120"/>
               </a:rPr>
-              <a:t>SLIDE 8 / 13   |   RESULT</a:t>
+              <a:t>SLIDE 8 / 14   |   RESULT</a:t>
             </a:r>
             <a:endParaRPr lang="en-US" sz="1100" dirty="0"/>
           </a:p>
@@ -10301,7 +11350,7 @@
                 <a:ea typeface="Calibri" pitchFamily="34" charset="-122"/>
                 <a:cs typeface="Calibri" pitchFamily="34" charset="-120"/>
               </a:rPr>
-              <a:t>9 / 13</a:t>
+              <a:t>9 / 14</a:t>
             </a:r>
             <a:endParaRPr lang="en-US" sz="2800" dirty="0"/>
           </a:p>
@@ -10360,7 +11409,7 @@
                 <a:ea typeface="Calibri" pitchFamily="34" charset="-122"/>
                 <a:cs typeface="Calibri" pitchFamily="34" charset="-120"/>
               </a:rPr>
-              <a:t>SLIDE 9 / 13   |   VIDEO</a:t>
+              <a:t>SLIDE 9 / 14   |   VIDEO</a:t>
             </a:r>
             <a:endParaRPr lang="en-US" sz="1100" dirty="0"/>
           </a:p>

</xml_diff>